<commit_message>
feat: add Adithya Ramesh and Akash Rajpurohit as speakers across presentation, notebook, and apps
</commit_message>
<xml_diff>
--- a/Multimodal-AI-in-Healthcare.pptx
+++ b/Multimodal-AI-in-Healthcare.pptx
@@ -4362,7 +4362,7 @@
         <p:spPr>
           <a:xfrm>
             <a:off x="1051560" y="5212080"/>
-            <a:ext cx="5486400" cy="347472"/>
+            <a:ext cx="5669280" cy="347472"/>
           </a:xfrm>
           <a:prstGeom prst="rect">
             <a:avLst/>
@@ -4384,13 +4384,13 @@
               </a:spcAft>
             </a:pPr>
             <a:r>
-              <a:rPr sz="1500" b="1" i="0">
+              <a:rPr sz="1300" b="1" i="0">
                 <a:solidFill>
                   <a:srgbClr val="F8FAFC"/>
                 </a:solidFill>
                 <a:latin typeface="Arial"/>
               </a:rPr>
-              <a:t>Presenter: Bezaleel Paul N</a:t>
+              <a:t>Speakers: Bezaleel Paul N · Adithya Ramesh · Akash Rajpurohit</a:t>
             </a:r>
           </a:p>
         </p:txBody>
@@ -4404,7 +4404,7 @@
         <p:spPr>
           <a:xfrm>
             <a:off x="1051560" y="5596128"/>
-            <a:ext cx="5486400" cy="347472"/>
+            <a:ext cx="5669280" cy="347472"/>
           </a:xfrm>
           <a:prstGeom prst="rect">
             <a:avLst/>
@@ -4445,8 +4445,8 @@
         </p:nvSpPr>
         <p:spPr>
           <a:xfrm>
-            <a:off x="6583680" y="5212080"/>
-            <a:ext cx="4572000" cy="347472"/>
+            <a:off x="6766560" y="5212080"/>
+            <a:ext cx="4389120" cy="347472"/>
           </a:xfrm>
           <a:prstGeom prst="rect">
             <a:avLst/>
@@ -4487,8 +4487,8 @@
         </p:nvSpPr>
         <p:spPr>
           <a:xfrm>
-            <a:off x="6583680" y="5596128"/>
-            <a:ext cx="4572000" cy="347472"/>
+            <a:off x="6766560" y="5596128"/>
+            <a:ext cx="4389120" cy="347472"/>
           </a:xfrm>
           <a:prstGeom prst="rect">
             <a:avLst/>
@@ -4672,7 +4672,7 @@
                 </a:solidFill>
                 <a:latin typeface="Arial"/>
               </a:rPr>
-              <a:t>Multimodal AI in Healthcare  |  IEEE Seminar  |  Presenter: Bezaleel Paul N</a:t>
+              <a:t>Multimodal AI in Healthcare  |  IEEE Seminar  |  Bezaleel · Adithya · Akash</a:t>
             </a:r>
           </a:p>
         </p:txBody>
@@ -6367,7 +6367,7 @@
                 </a:solidFill>
                 <a:latin typeface="Arial"/>
               </a:rPr>
-              <a:t>Multimodal AI in Healthcare  |  IEEE Seminar  |  Presenter: Bezaleel Paul N</a:t>
+              <a:t>Multimodal AI in Healthcare  |  IEEE Seminar  |  Bezaleel · Adithya · Akash</a:t>
             </a:r>
           </a:p>
         </p:txBody>
@@ -7775,7 +7775,7 @@
                 </a:solidFill>
                 <a:latin typeface="Arial"/>
               </a:rPr>
-              <a:t>Multimodal AI in Healthcare  |  IEEE Seminar  |  Presenter: Bezaleel Paul N</a:t>
+              <a:t>Multimodal AI in Healthcare  |  IEEE Seminar  |  Bezaleel · Adithya · Akash</a:t>
             </a:r>
           </a:p>
         </p:txBody>
@@ -9100,7 +9100,7 @@
                 </a:solidFill>
                 <a:latin typeface="Arial"/>
               </a:rPr>
-              <a:t>Multimodal AI in Healthcare  |  IEEE Seminar  |  Presenter: Bezaleel Paul N</a:t>
+              <a:t>Multimodal AI in Healthcare  |  IEEE Seminar  |  Bezaleel · Adithya · Akash</a:t>
             </a:r>
           </a:p>
         </p:txBody>
@@ -10472,7 +10472,7 @@
                 </a:solidFill>
                 <a:latin typeface="Arial"/>
               </a:rPr>
-              <a:t>Multimodal AI in Healthcare  |  IEEE Seminar  |  Presenter: Bezaleel Paul N</a:t>
+              <a:t>Multimodal AI in Healthcare  |  IEEE Seminar  |  Bezaleel · Adithya · Akash</a:t>
             </a:r>
           </a:p>
         </p:txBody>
@@ -11683,7 +11683,7 @@
                 </a:solidFill>
                 <a:latin typeface="Arial"/>
               </a:rPr>
-              <a:t>Presenter: Bezaleel Paul N  |  B.Tech CSE</a:t>
+              <a:t>Speakers: Bezaleel Paul N · Adithya Ramesh · Akash Rajpurohit</a:t>
             </a:r>
           </a:p>
         </p:txBody>
@@ -12091,7 +12091,7 @@
                 </a:solidFill>
                 <a:latin typeface="Arial"/>
               </a:rPr>
-              <a:t>Multimodal AI in Healthcare  |  IEEE Seminar  |  Presenter: Bezaleel Paul N</a:t>
+              <a:t>Multimodal AI in Healthcare  |  IEEE Seminar  |  Bezaleel · Adithya · Akash</a:t>
             </a:r>
           </a:p>
         </p:txBody>
@@ -14195,7 +14195,7 @@
                 </a:solidFill>
                 <a:latin typeface="Arial"/>
               </a:rPr>
-              <a:t>Multimodal AI in Healthcare  |  IEEE Seminar  |  Presenter: Bezaleel Paul N</a:t>
+              <a:t>Multimodal AI in Healthcare  |  IEEE Seminar  |  Bezaleel · Adithya · Akash</a:t>
             </a:r>
           </a:p>
         </p:txBody>
@@ -16269,7 +16269,7 @@
                 </a:solidFill>
                 <a:latin typeface="Arial"/>
               </a:rPr>
-              <a:t>Multimodal AI in Healthcare  |  IEEE Seminar  |  Presenter: Bezaleel Paul N</a:t>
+              <a:t>Multimodal AI in Healthcare  |  IEEE Seminar  |  Bezaleel · Adithya · Akash</a:t>
             </a:r>
           </a:p>
         </p:txBody>
@@ -17869,7 +17869,7 @@
                 </a:solidFill>
                 <a:latin typeface="Arial"/>
               </a:rPr>
-              <a:t>Multimodal AI in Healthcare  |  IEEE Seminar  |  Presenter: Bezaleel Paul N</a:t>
+              <a:t>Multimodal AI in Healthcare  |  IEEE Seminar  |  Bezaleel · Adithya · Akash</a:t>
             </a:r>
           </a:p>
         </p:txBody>
@@ -20125,7 +20125,7 @@
                 </a:solidFill>
                 <a:latin typeface="Arial"/>
               </a:rPr>
-              <a:t>Multimodal AI in Healthcare  |  IEEE Seminar  |  Presenter: Bezaleel Paul N</a:t>
+              <a:t>Multimodal AI in Healthcare  |  IEEE Seminar  |  Bezaleel · Adithya · Akash</a:t>
             </a:r>
           </a:p>
         </p:txBody>
@@ -22111,7 +22111,7 @@
                 </a:solidFill>
                 <a:latin typeface="Arial"/>
               </a:rPr>
-              <a:t>Multimodal AI in Healthcare  |  IEEE Seminar  |  Presenter: Bezaleel Paul N</a:t>
+              <a:t>Multimodal AI in Healthcare  |  IEEE Seminar  |  Bezaleel · Adithya · Akash</a:t>
             </a:r>
           </a:p>
         </p:txBody>
@@ -24034,7 +24034,7 @@
                 </a:solidFill>
                 <a:latin typeface="Arial"/>
               </a:rPr>
-              <a:t>Multimodal AI in Healthcare  |  IEEE Seminar  |  Presenter: Bezaleel Paul N</a:t>
+              <a:t>Multimodal AI in Healthcare  |  IEEE Seminar  |  Bezaleel · Adithya · Akash</a:t>
             </a:r>
           </a:p>
         </p:txBody>
@@ -25615,7 +25615,7 @@
                 </a:solidFill>
                 <a:latin typeface="Arial"/>
               </a:rPr>
-              <a:t>Multimodal AI in Healthcare  |  IEEE Seminar  |  Presenter: Bezaleel Paul N</a:t>
+              <a:t>Multimodal AI in Healthcare  |  IEEE Seminar  |  Bezaleel · Adithya · Akash</a:t>
             </a:r>
           </a:p>
         </p:txBody>

</xml_diff>